<commit_message>
ONB 13: rebuild from updated prompter (5 slides, visual checklist)
Co-Authored-By: Claude Opus 5.5 <noreply@anthropic.com>
Claude-Session: https://claude.ai/code/session_01PSmnUj1LvutfXzpzQBGsxa
</commit_message>
<xml_diff>
--- a/onboarding/presentaciones/ONB13_Checklist_final.pptx
+++ b/onboarding/presentaciones/ONB13_Checklist_final.pptx
@@ -9,9 +9,10 @@
     <p:sldId id="257" r:id="rId3"/>
     <p:sldId id="258" r:id="rId4"/>
     <p:sldId id="259" r:id="rId5"/>
+    <p:sldId id="260" r:id="rId6"/>
   </p:sldIdLst>
   <p:notesMasterIdLst>
-    <p:notesMasterId r:id="rId6"/>
+    <p:notesMasterId r:id="rId7"/>
   </p:notesMasterIdLst>
   <p:sldSz cx="12192000" cy="6858000"/>
   <p:notesSz cx="6858000" cy="12192000"/>
@@ -505,9 +506,9 @@
           <a:p>
             <a:r>
               <a:rPr lang="en-US" dirty="0"/>
-              <a:t>Antes de pasar al Módulo 1, quiero que hagamos una última revisión rápida.
-Esta primera semana no era para avanzar rápido ni para consumir contenido. Era para dejar instalado tu sistema de trabajo dentro de AT WORK.
-Así que antes de seguir, revisa este checklist conmigo.</a:t>
+              <a:t>Antes de empezar el Módulo 1, quiero que hagamos una última revisión juntas.
+Esta primera semana no era para avanzar rápido ni para consumir contenido. Era para dejar armado tu sistema de trabajo dentro de AT WORK y asegurarnos de que sabes exactamente cómo moverte dentro del programa.
+Así que antes de seguir, quiero que revises este checklist conmigo. No se trata solo de haber visto los videos: se trata de haber completado las acciones que te van a permitir empezar el proceso con claridad, organización y un punto de partida real.</a:t>
             </a:r>
             <a:endParaRPr lang="en-US" dirty="0"/>
           </a:p>
@@ -595,12 +596,10 @@
           <a:p>
             <a:r>
               <a:rPr lang="en-US" dirty="0"/>
-              <a:t>Primero, confirma que ya viste todo el onboarding.
-Que firmaste tu Acuerdo de Trabajo y lo subiste a 01 · MI CONTEXTO PROFESIONAL dentro de tu Drive.
-Que entraste a la Comunidad AT WORK y te uniste a sus canales.
-Que ya te presentaste.
-Y que confirmaste que estás recibiendo correctamente los emails de AT WORK. Revisa también Spam y Promociones. Si encontraste alguno ahí, marca el remitente como seguro o agrégalo a tus contactos.
-Si alguno de estos puntos falta, resuélvelo antes de avanzar.</a:t>
+              <a:t>Primero, revisa que hayas completado bien tu onboarding.
+Quiero que confirmes que viste todas las clases con atención, que firmaste tu Acuerdo de Trabajo y lo subiste a tu carpeta personal de AT WORK.
+También deberías haber completado tu Starting Point. Ese es tu punto de partida: incluye tu autoevaluación inicial y una producción espontánea en audio o video para que podamos registrar cómo estás hoy y después comparar tu progreso con evidencia real.
+Si alguno de estos puntos todavía falta, complétalo antes de avanzar.</a:t>
             </a:r>
             <a:endParaRPr lang="en-US" dirty="0"/>
           </a:p>
@@ -688,15 +687,10 @@
           <a:p>
             <a:r>
               <a:rPr lang="en-US" dirty="0"/>
-              <a:t>Ahora revisa la parte operativa del proceso.
-¿Abriste tu carpeta personal de AT WORK?
-¿Completaste tu Starting Point?
-¿Subiste entre tres y cinco materiales reales de tu trabajo?
-¿Reservaste en tu calendario tus bloques semanales de práctica?
-¿Sabes dónde pedir feedback y qué información incluir cuando lo pides?
-¿Entendiste que cada semana vas a completar tu Weekly Report y guardarlo en tu Drive?
-¿Tienes claro cuál es tu foco actual?
-No necesito que todo esté perfecto. Pero sí quiero que este sistema esté armado, porque después nos permite concentrarnos en lo importante: entrenar tu inglés y tu comunicación.</a:t>
+              <a:t>Ahora revisemos la comunidad.
+A esta altura ya deberías haberte unido a AT WORK Community y también a todos sus canales: Announcements, Weekly Reports, Wins, Questions &amp; Support y Connect &amp; Share.
+Y dentro de Connect &amp; Share, deberías haber hecho tu presentación para que el resto de la comunidad pueda conocerte.
+La idea es que desde el principio sepas dónde compartir cada cosa y puedas usar la comunidad como parte real de tu proceso, no como un espacio que simplemente está ahí.</a:t>
             </a:r>
             <a:endParaRPr lang="en-US" dirty="0"/>
           </a:p>
@@ -784,10 +778,10 @@
           <a:p>
             <a:r>
               <a:rPr lang="en-US" dirty="0"/>
-              <a:t>Si todo esto está listo, ya puedes empezar el Módulo 1: Activate Your English.
-A partir de ahora no necesitas hacer todo de golpe. Sigue el foco de cada semana, usa tu Weekly System, trae tu trabajo real al proceso y pide ayuda cuando la necesites.
-No marques esta clase como completada hasta que hayas terminado todos los puntos del checklist.
-Cuando eso esté listo, tu onboarding está completo.</a:t>
+              <a:t>Después, revisa que tengas armado tu sistema de trabajo.
+Deberías haber abierto y ubicado tu carpeta personal de AT WORK, subido entre tres y cinco materiales reales de tu trabajo y reservado en tu calendario tus bloques semanales de práctica.
+También quiero que tengas claro dónde y cómo pedir feedback, cómo funciona tu Weekly Report y dónde vas a guardarlo cada semana.
+Y, sobre todo, que tengas claro cuál es tu foco inicial. No necesitas tener todo resuelto ni saber exactamente qué vas a trabajar durante los próximos cinco meses. Para eso está el proceso. Pero sí quiero que empieces sabiendo desde dónde partes y cuál es la prioridad ahora.</a:t>
             </a:r>
             <a:endParaRPr lang="en-US" dirty="0"/>
           </a:p>
@@ -811,6 +805,98 @@
             <a:fld id="{F7021451-1387-4CA6-816F-3879F97B5CBC}" type="slidenum">
               <a:rPr lang="en-US"/>
               <a:t>4</a:t>
+            </a:fld>
+            <a:endParaRPr lang="en-US"/>
+          </a:p>
+        </p:txBody>
+      </p:sp>
+    </p:spTree>
+    <p:extLst>
+      <p:ext uri="{BB962C8B-B14F-4D97-AF65-F5344CB8AC3E}">
+        <p14:creationId xmlns:p14="http://schemas.microsoft.com/office/powerpoint/2010/main" val="1024086991"/>
+      </p:ext>
+    </p:extLst>
+  </p:cSld>
+  <p:clrMapOvr>
+    <a:masterClrMapping/>
+  </p:clrMapOvr>
+</p:notes>
+</file>
+
+<file path=ppt/notesSlides/notesSlide5.xml><?xml version="1.0" encoding="utf-8"?>
+<p:notes xmlns:a="http://schemas.openxmlformats.org/drawingml/2006/main" xmlns:r="http://schemas.openxmlformats.org/officeDocument/2006/relationships" xmlns:p="http://schemas.openxmlformats.org/presentationml/2006/main">
+  <p:cSld>
+    <p:spTree>
+      <p:nvGrpSpPr>
+        <p:cNvPr id="1" name=""/>
+        <p:cNvGrpSpPr/>
+        <p:nvPr/>
+      </p:nvGrpSpPr>
+      <p:grpSpPr>
+        <a:xfrm>
+          <a:off x="0" y="0"/>
+          <a:ext cx="0" cy="0"/>
+          <a:chOff x="0" y="0"/>
+          <a:chExt cx="0" cy="0"/>
+        </a:xfrm>
+      </p:grpSpPr>
+      <p:sp>
+        <p:nvSpPr>
+          <p:cNvPr id="2" name="Slide Image Placeholder 1"/>
+          <p:cNvSpPr>
+            <a:spLocks noGrp="1" noRot="1" noChangeAspect="1"/>
+          </p:cNvSpPr>
+          <p:nvPr>
+            <p:ph type="sldImg"/>
+          </p:nvPr>
+        </p:nvSpPr>
+        <p:spPr/>
+      </p:sp>
+      <p:sp>
+        <p:nvSpPr>
+          <p:cNvPr id="3" name="Notes Placeholder 2"/>
+          <p:cNvSpPr>
+            <a:spLocks noGrp="1"/>
+          </p:cNvSpPr>
+          <p:nvPr>
+            <p:ph type="body" idx="1"/>
+          </p:nvPr>
+        </p:nvSpPr>
+        <p:spPr/>
+        <p:txBody>
+          <a:bodyPr/>
+          <a:lstStyle/>
+          <a:p>
+            <a:r>
+              <a:rPr lang="en-US" dirty="0"/>
+              <a:t>Y queda un último paso.
+Cuando hayas completado todo lo anterior, escríbeme para que definamos y dejemos agendado tu horario recurrente de sesiones 1:1.
+No marques esta clase como completada hasta haber terminado todos los puntos del checklist.
+Cuando todo esto esté listo, tu onboarding está completo y ya puedes empezar el Módulo 1.
+A partir de ahí, no necesitas hacer todo de golpe. Sigue el foco de cada semana, usa tu Weekly System, trae tu trabajo real al proceso y pide ayuda cuando la necesites.</a:t>
+            </a:r>
+            <a:endParaRPr lang="en-US" dirty="0"/>
+          </a:p>
+        </p:txBody>
+      </p:sp>
+      <p:sp>
+        <p:nvSpPr>
+          <p:cNvPr id="4" name="Slide Number Placeholder 3"/>
+          <p:cNvSpPr>
+            <a:spLocks noGrp="1"/>
+          </p:cNvSpPr>
+          <p:nvPr>
+            <p:ph type="sldNum" sz="quarter" idx="10"/>
+          </p:nvPr>
+        </p:nvSpPr>
+        <p:spPr/>
+        <p:txBody>
+          <a:bodyPr/>
+          <a:lstStyle/>
+          <a:p>
+            <a:fld id="{F7021451-1387-4CA6-816F-3879F97B5CBC}" type="slidenum">
+              <a:rPr lang="en-US"/>
+              <a:t>5</a:t>
             </a:fld>
             <a:endParaRPr lang="en-US"/>
           </a:p>
@@ -1483,7 +1569,7 @@
                 <a:ea typeface="Open Sans" pitchFamily="34" charset="-122"/>
                 <a:cs typeface="Open Sans" pitchFamily="34" charset="-120"/>
               </a:rPr>
-              <a:t>Onboarding y Acuerdo de Trabajo</a:t>
+              <a:t>Tu onboarding</a:t>
             </a:r>
             <a:endParaRPr lang="en-US" sz="1500" dirty="0"/>
           </a:p>
@@ -1602,7 +1688,7 @@
                 <a:ea typeface="Open Sans" pitchFamily="34" charset="-122"/>
                 <a:cs typeface="Open Sans" pitchFamily="34" charset="-120"/>
               </a:rPr>
-              <a:t>Comunidad y emails</a:t>
+              <a:t>Tu comunidad</a:t>
             </a:r>
             <a:endParaRPr lang="en-US" sz="1500" dirty="0"/>
           </a:p>
@@ -1721,7 +1807,7 @@
                 <a:ea typeface="Open Sans" pitchFamily="34" charset="-122"/>
                 <a:cs typeface="Open Sans" pitchFamily="34" charset="-120"/>
               </a:rPr>
-              <a:t>Tu Drive y tus materiales</a:t>
+              <a:t>Tu sistema de trabajo</a:t>
             </a:r>
             <a:endParaRPr lang="en-US" sz="1500" dirty="0"/>
           </a:p>
@@ -1840,7 +1926,7 @@
                 <a:ea typeface="Open Sans" pitchFamily="34" charset="-122"/>
                 <a:cs typeface="Open Sans" pitchFamily="34" charset="-120"/>
               </a:rPr>
-              <a:t>Tu práctica y tu foco</a:t>
+              <a:t>Último paso</a:t>
             </a:r>
             <a:endParaRPr lang="en-US" sz="1500" dirty="0"/>
           </a:p>
@@ -1949,7 +2035,7 @@
                 <a:ea typeface="Open Sans" pitchFamily="34" charset="-122"/>
                 <a:cs typeface="Open Sans" pitchFamily="34" charset="-120"/>
               </a:rPr>
-              <a:t>   ·   02 / 04</a:t>
+              <a:t>   ·   02 / 05</a:t>
             </a:r>
             <a:endParaRPr lang="en-US" sz="1100" dirty="0"/>
           </a:p>
@@ -1964,7 +2050,7 @@
         <p:spPr>
           <a:xfrm>
             <a:off x="640080" y="1280160"/>
-            <a:ext cx="3429000" cy="1104392"/>
+            <a:ext cx="3429000" cy="620776"/>
           </a:xfrm>
           <a:prstGeom prst="rect">
             <a:avLst/>
@@ -1991,7 +2077,7 @@
                 <a:ea typeface="Source Serif Pro" pitchFamily="34" charset="-122"/>
                 <a:cs typeface="Source Serif Pro" pitchFamily="34" charset="-120"/>
               </a:rPr>
-              <a:t>Checklist · Primeros pasos</a:t>
+              <a:t>Tu onboarding</a:t>
             </a:r>
             <a:endParaRPr lang="en-US" sz="3400" dirty="0"/>
           </a:p>
@@ -2005,7 +2091,7 @@
         </p:nvSpPr>
         <p:spPr>
           <a:xfrm>
-            <a:off x="640080" y="2521712"/>
+            <a:off x="640080" y="2038096"/>
             <a:ext cx="3291840" cy="640080"/>
           </a:xfrm>
           <a:prstGeom prst="rect">
@@ -2030,7 +2116,7 @@
                 <a:ea typeface="Source Serif Pro" pitchFamily="34" charset="-122"/>
                 <a:cs typeface="Source Serif Pro" pitchFamily="34" charset="-120"/>
               </a:rPr>
-              <a:t>Si alguno falta, resuélvelo antes de avanzar</a:t>
+              <a:t>Si alguno de estos puntos falta, complétalo antes de avanzar</a:t>
             </a:r>
             <a:endParaRPr lang="en-US" sz="1600" dirty="0"/>
           </a:p>
@@ -2045,11 +2131,11 @@
         <p:spPr>
           <a:xfrm>
             <a:off x="4389120" y="1280160"/>
-            <a:ext cx="7159752" cy="868680"/>
+            <a:ext cx="7159752" cy="914400"/>
           </a:xfrm>
           <a:prstGeom prst="roundRect">
             <a:avLst>
-              <a:gd name="adj" fmla="val 16842"/>
+              <a:gd name="adj" fmla="val 16000"/>
             </a:avLst>
           </a:prstGeom>
           <a:solidFill>
@@ -2086,7 +2172,7 @@
         </p:blipFill>
         <p:spPr>
           <a:xfrm>
-            <a:off x="4663440" y="1540764"/>
+            <a:off x="4663440" y="1563624"/>
             <a:ext cx="347472" cy="347472"/>
           </a:xfrm>
           <a:prstGeom prst="rect">
@@ -2103,7 +2189,7 @@
         <p:spPr>
           <a:xfrm>
             <a:off x="5212080" y="1280160"/>
-            <a:ext cx="6153912" cy="868680"/>
+            <a:ext cx="6153912" cy="914400"/>
           </a:xfrm>
           <a:prstGeom prst="rect">
             <a:avLst/>
@@ -2119,7 +2205,7 @@
               <a:buNone/>
             </a:pPr>
             <a:r>
-              <a:rPr lang="en-US" sz="1500" dirty="0">
+              <a:rPr lang="en-US" sz="1600" dirty="0">
                 <a:solidFill>
                   <a:srgbClr val="3F1E0D"/>
                 </a:solidFill>
@@ -2127,9 +2213,9 @@
                 <a:ea typeface="Open Sans" pitchFamily="34" charset="-122"/>
                 <a:cs typeface="Open Sans" pitchFamily="34" charset="-120"/>
               </a:rPr>
-              <a:t>Viste todo el onboarding</a:t>
-            </a:r>
-            <a:endParaRPr lang="en-US" sz="1500" dirty="0"/>
+              <a:t>Haber visto todo el onboarding con atención</a:t>
+            </a:r>
+            <a:endParaRPr lang="en-US" sz="1600" dirty="0"/>
           </a:p>
         </p:txBody>
       </p:sp>
@@ -2141,12 +2227,12 @@
         </p:nvSpPr>
         <p:spPr>
           <a:xfrm>
-            <a:off x="4389120" y="2331720"/>
-            <a:ext cx="7159752" cy="868680"/>
+            <a:off x="4389120" y="2377440"/>
+            <a:ext cx="7159752" cy="914400"/>
           </a:xfrm>
           <a:prstGeom prst="roundRect">
             <a:avLst>
-              <a:gd name="adj" fmla="val 16842"/>
+              <a:gd name="adj" fmla="val 16000"/>
             </a:avLst>
           </a:prstGeom>
           <a:solidFill>
@@ -2183,7 +2269,7 @@
         </p:blipFill>
         <p:spPr>
           <a:xfrm>
-            <a:off x="4663440" y="2592324"/>
+            <a:off x="4663440" y="2660904"/>
             <a:ext cx="347472" cy="347472"/>
           </a:xfrm>
           <a:prstGeom prst="rect">
@@ -2199,8 +2285,8 @@
         </p:nvSpPr>
         <p:spPr>
           <a:xfrm>
-            <a:off x="5212080" y="2331720"/>
-            <a:ext cx="6153912" cy="868680"/>
+            <a:off x="5212080" y="2377440"/>
+            <a:ext cx="6153912" cy="914400"/>
           </a:xfrm>
           <a:prstGeom prst="rect">
             <a:avLst/>
@@ -2216,7 +2302,7 @@
               <a:buNone/>
             </a:pPr>
             <a:r>
-              <a:rPr lang="en-US" sz="1500" dirty="0">
+              <a:rPr lang="en-US" sz="1600" dirty="0">
                 <a:solidFill>
                   <a:srgbClr val="3F1E0D"/>
                 </a:solidFill>
@@ -2224,13 +2310,13 @@
                 <a:ea typeface="Open Sans" pitchFamily="34" charset="-122"/>
                 <a:cs typeface="Open Sans" pitchFamily="34" charset="-120"/>
               </a:rPr>
-              <a:t>Firmaste tu Acuerdo de Trabajo y lo subiste a </a:t>
+              <a:t>Haber firmado el </a:t>
             </a:r>
             <a:pPr indent="0" marL="0">
               <a:buNone/>
             </a:pPr>
             <a:r>
-              <a:rPr lang="en-US" sz="1500" b="1" dirty="0">
+              <a:rPr lang="en-US" sz="1600" b="1" dirty="0">
                 <a:solidFill>
                   <a:srgbClr val="3F1E0D"/>
                 </a:solidFill>
@@ -2238,9 +2324,23 @@
                 <a:ea typeface="Open Sans" pitchFamily="34" charset="-122"/>
                 <a:cs typeface="Open Sans" pitchFamily="34" charset="-120"/>
               </a:rPr>
-              <a:t>01 · MI CONTEXTO PROFESIONAL</a:t>
-            </a:r>
-            <a:endParaRPr lang="en-US" sz="1500" dirty="0"/>
+              <a:t>Acuerdo de Trabajo</a:t>
+            </a:r>
+            <a:pPr indent="0" marL="0">
+              <a:buNone/>
+            </a:pPr>
+            <a:r>
+              <a:rPr lang="en-US" sz="1600" dirty="0">
+                <a:solidFill>
+                  <a:srgbClr val="3F1E0D"/>
+                </a:solidFill>
+                <a:latin typeface="Open Sans" pitchFamily="34" charset="0"/>
+                <a:ea typeface="Open Sans" pitchFamily="34" charset="-122"/>
+                <a:cs typeface="Open Sans" pitchFamily="34" charset="-120"/>
+              </a:rPr>
+              <a:t> y haberlo subido a tu carpeta personal de AT WORK</a:t>
+            </a:r>
+            <a:endParaRPr lang="en-US" sz="1600" dirty="0"/>
           </a:p>
         </p:txBody>
       </p:sp>
@@ -2252,12 +2352,12 @@
         </p:nvSpPr>
         <p:spPr>
           <a:xfrm>
-            <a:off x="4389120" y="3383280"/>
-            <a:ext cx="7159752" cy="868680"/>
+            <a:off x="4389120" y="3474720"/>
+            <a:ext cx="7159752" cy="914400"/>
           </a:xfrm>
           <a:prstGeom prst="roundRect">
             <a:avLst>
-              <a:gd name="adj" fmla="val 16842"/>
+              <a:gd name="adj" fmla="val 16000"/>
             </a:avLst>
           </a:prstGeom>
           <a:solidFill>
@@ -2294,7 +2394,7 @@
         </p:blipFill>
         <p:spPr>
           <a:xfrm>
-            <a:off x="4663440" y="3643884"/>
+            <a:off x="4663440" y="3758184"/>
             <a:ext cx="347472" cy="347472"/>
           </a:xfrm>
           <a:prstGeom prst="rect">
@@ -2310,8 +2410,8 @@
         </p:nvSpPr>
         <p:spPr>
           <a:xfrm>
-            <a:off x="5212080" y="3383280"/>
-            <a:ext cx="6153912" cy="868680"/>
+            <a:off x="5212080" y="3474720"/>
+            <a:ext cx="6153912" cy="914400"/>
           </a:xfrm>
           <a:prstGeom prst="rect">
             <a:avLst/>
@@ -2327,7 +2427,7 @@
               <a:buNone/>
             </a:pPr>
             <a:r>
-              <a:rPr lang="en-US" sz="1500" dirty="0">
+              <a:rPr lang="en-US" sz="1600" dirty="0">
                 <a:solidFill>
                   <a:srgbClr val="3F1E0D"/>
                 </a:solidFill>
@@ -2335,9 +2435,37 @@
                 <a:ea typeface="Open Sans" pitchFamily="34" charset="-122"/>
                 <a:cs typeface="Open Sans" pitchFamily="34" charset="-120"/>
               </a:rPr>
-              <a:t>Entraste a la Comunidad AT WORK y te uniste a sus canales</a:t>
-            </a:r>
-            <a:endParaRPr lang="en-US" sz="1500" dirty="0"/>
+              <a:t>Haber completado tu </a:t>
+            </a:r>
+            <a:pPr indent="0" marL="0">
+              <a:buNone/>
+            </a:pPr>
+            <a:r>
+              <a:rPr lang="en-US" sz="1600" b="1" dirty="0">
+                <a:solidFill>
+                  <a:srgbClr val="3F1E0D"/>
+                </a:solidFill>
+                <a:latin typeface="Open Sans" pitchFamily="34" charset="0"/>
+                <a:ea typeface="Open Sans" pitchFamily="34" charset="-122"/>
+                <a:cs typeface="Open Sans" pitchFamily="34" charset="-120"/>
+              </a:rPr>
+              <a:t>Starting Point</a:t>
+            </a:r>
+            <a:pPr indent="0" marL="0">
+              <a:buNone/>
+            </a:pPr>
+            <a:r>
+              <a:rPr lang="en-US" sz="1600" dirty="0">
+                <a:solidFill>
+                  <a:srgbClr val="3F1E0D"/>
+                </a:solidFill>
+                <a:latin typeface="Open Sans" pitchFamily="34" charset="0"/>
+                <a:ea typeface="Open Sans" pitchFamily="34" charset="-122"/>
+                <a:cs typeface="Open Sans" pitchFamily="34" charset="-120"/>
+              </a:rPr>
+              <a:t>: autoevaluación inicial + audio o video espontáneo de 2–3 minutos</a:t>
+            </a:r>
+            <a:endParaRPr lang="en-US" sz="1600" dirty="0"/>
           </a:p>
         </p:txBody>
       </p:sp>
@@ -2349,20 +2477,20 @@
         </p:nvSpPr>
         <p:spPr>
           <a:xfrm>
-            <a:off x="4389120" y="4434840"/>
-            <a:ext cx="7159752" cy="868680"/>
+            <a:off x="4389120" y="4983480"/>
+            <a:ext cx="7159752" cy="1371600"/>
           </a:xfrm>
           <a:prstGeom prst="roundRect">
             <a:avLst>
-              <a:gd name="adj" fmla="val 16842"/>
+              <a:gd name="adj" fmla="val 10667"/>
             </a:avLst>
           </a:prstGeom>
           <a:solidFill>
-            <a:srgbClr val="FFFDF9"/>
+            <a:srgbClr val="FBF2D0"/>
           </a:solidFill>
           <a:ln w="12700">
             <a:solidFill>
-              <a:srgbClr val="FFFDF9"/>
+              <a:srgbClr val="FBF2D0"/>
             </a:solidFill>
             <a:prstDash val="solid"/>
           </a:ln>
@@ -2375,9 +2503,34 @@
           </a:effectLst>
         </p:spPr>
       </p:sp>
+      <p:sp>
+        <p:nvSpPr>
+          <p:cNvPr id="17" name="Shape 10"/>
+          <p:cNvSpPr/>
+          <p:nvPr/>
+        </p:nvSpPr>
+        <p:spPr>
+          <a:xfrm>
+            <a:off x="4754880" y="5280660"/>
+            <a:ext cx="777240" cy="777240"/>
+          </a:xfrm>
+          <a:prstGeom prst="ellipse">
+            <a:avLst/>
+          </a:prstGeom>
+          <a:solidFill>
+            <a:srgbClr val="C68C6C"/>
+          </a:solidFill>
+          <a:ln w="12700">
+            <a:solidFill>
+              <a:srgbClr val="C68C6C"/>
+            </a:solidFill>
+            <a:prstDash val="solid"/>
+          </a:ln>
+        </p:spPr>
+      </p:sp>
       <p:pic>
         <p:nvPicPr>
-          <p:cNvPr id="17" name="Image 4" descr="preencoded.png">    </p:cNvPr>
+          <p:cNvPr id="18" name="Image 4" descr="preencoded.png">    </p:cNvPr>
           <p:cNvPicPr>
             <a:picLocks noChangeAspect="1"/>
           </p:cNvPicPr>
@@ -2391,8 +2544,8 @@
         </p:blipFill>
         <p:spPr>
           <a:xfrm>
-            <a:off x="4663440" y="4695444"/>
-            <a:ext cx="347472" cy="347472"/>
+            <a:off x="4964735" y="5490515"/>
+            <a:ext cx="357530" cy="357530"/>
           </a:xfrm>
           <a:prstGeom prst="rect">
             <a:avLst/>
@@ -2401,14 +2554,14 @@
       </p:pic>
       <p:sp>
         <p:nvSpPr>
-          <p:cNvPr id="18" name="Text 10"/>
+          <p:cNvPr id="19" name="Text 11"/>
           <p:cNvSpPr txBox="1"/>
           <p:nvPr/>
         </p:nvSpPr>
         <p:spPr>
           <a:xfrm>
-            <a:off x="5212080" y="4434840"/>
-            <a:ext cx="6153912" cy="868680"/>
+            <a:off x="5852160" y="4983480"/>
+            <a:ext cx="5376672" cy="1371600"/>
           </a:xfrm>
           <a:prstGeom prst="rect">
             <a:avLst/>
@@ -2421,103 +2574,29 @@
           <a:lstStyle/>
           <a:p>
             <a:pPr indent="0" marL="0">
-              <a:buNone/>
-            </a:pPr>
-            <a:r>
-              <a:rPr lang="en-US" sz="1500" dirty="0">
-                <a:solidFill>
-                  <a:srgbClr val="3F1E0D"/>
+              <a:spcAft>
+                <a:spcPts val="500"/>
+              </a:spcAft>
+              <a:buNone/>
+            </a:pPr>
+            <a:r>
+              <a:rPr lang="en-US" sz="1700" b="1" dirty="0">
+                <a:solidFill>
+                  <a:srgbClr val="81552E"/>
                 </a:solidFill>
                 <a:latin typeface="Open Sans" pitchFamily="34" charset="0"/>
                 <a:ea typeface="Open Sans" pitchFamily="34" charset="-122"/>
                 <a:cs typeface="Open Sans" pitchFamily="34" charset="-120"/>
               </a:rPr>
-              <a:t>Ya te presentaste</a:t>
-            </a:r>
-            <a:endParaRPr lang="en-US" sz="1500" dirty="0"/>
-          </a:p>
-        </p:txBody>
-      </p:sp>
-      <p:sp>
-        <p:nvSpPr>
-          <p:cNvPr id="19" name="Shape 11"/>
-          <p:cNvSpPr/>
-          <p:nvPr/>
-        </p:nvSpPr>
-        <p:spPr>
-          <a:xfrm>
-            <a:off x="4389120" y="5486400"/>
-            <a:ext cx="7159752" cy="868680"/>
-          </a:xfrm>
-          <a:prstGeom prst="roundRect">
-            <a:avLst>
-              <a:gd name="adj" fmla="val 16842"/>
-            </a:avLst>
-          </a:prstGeom>
-          <a:solidFill>
-            <a:srgbClr val="FFFDF9"/>
-          </a:solidFill>
-          <a:ln w="12700">
-            <a:solidFill>
-              <a:srgbClr val="FFFDF9"/>
-            </a:solidFill>
-            <a:prstDash val="solid"/>
-          </a:ln>
-          <a:effectLst>
-            <a:outerShdw sx="100000" sy="100000" kx="0" ky="0" algn="bl" rotWithShape="0" blurRad="177800" dist="38100" dir="5400000">
-              <a:srgbClr val="3F1E0D">
-                <a:alpha val="10000"/>
-              </a:srgbClr>
-            </a:outerShdw>
-          </a:effectLst>
-        </p:spPr>
-      </p:sp>
-      <p:pic>
-        <p:nvPicPr>
-          <p:cNvPr id="20" name="Image 5" descr="preencoded.png">    </p:cNvPr>
-          <p:cNvPicPr>
-            <a:picLocks noChangeAspect="1"/>
-          </p:cNvPicPr>
-          <p:nvPr/>
-        </p:nvPicPr>
-        <p:blipFill>
-          <a:blip r:embed="rId6"/>
-          <a:stretch>
-            <a:fillRect/>
-          </a:stretch>
-        </p:blipFill>
-        <p:spPr>
-          <a:xfrm>
-            <a:off x="4663440" y="5747004"/>
-            <a:ext cx="347472" cy="347472"/>
-          </a:xfrm>
-          <a:prstGeom prst="rect">
-            <a:avLst/>
-          </a:prstGeom>
-        </p:spPr>
-      </p:pic>
-      <p:sp>
-        <p:nvSpPr>
-          <p:cNvPr id="21" name="Text 12"/>
-          <p:cNvSpPr txBox="1"/>
-          <p:nvPr/>
-        </p:nvSpPr>
-        <p:spPr>
-          <a:xfrm>
-            <a:off x="5212080" y="5486400"/>
-            <a:ext cx="6153912" cy="868680"/>
-          </a:xfrm>
-          <a:prstGeom prst="rect">
-            <a:avLst/>
-          </a:prstGeom>
-          <a:noFill/>
-          <a:ln/>
-        </p:spPr>
-        <p:txBody>
-          <a:bodyPr wrap="square" lIns="0" tIns="0" rIns="0" bIns="0" rtlCol="0" anchor="ctr"/>
-          <a:lstStyle/>
+              <a:t>Tu Starting Point es tu punto de partida</a:t>
+            </a:r>
+            <a:endParaRPr lang="en-US" sz="1700" dirty="0"/>
+          </a:p>
           <a:p>
             <a:pPr indent="0" marL="0">
+              <a:spcAft>
+                <a:spcPts val="500"/>
+              </a:spcAft>
               <a:buNone/>
             </a:pPr>
             <a:r>
@@ -2529,9 +2608,9 @@
                 <a:ea typeface="Open Sans" pitchFamily="34" charset="-122"/>
                 <a:cs typeface="Open Sans" pitchFamily="34" charset="-120"/>
               </a:rPr>
-              <a:t>Recibes correctamente los emails de AT WORK (revisa también Spam y Promociones)</a:t>
-            </a:r>
-            <a:endParaRPr lang="en-US" sz="1500" dirty="0"/>
+              <a:t>Registra cómo estás hoy para que después podamos comparar tu progreso con evidencia real.</a:t>
+            </a:r>
+            <a:endParaRPr lang="en-US" sz="1700" dirty="0"/>
           </a:p>
         </p:txBody>
       </p:sp>
@@ -2638,7 +2717,7 @@
                 <a:ea typeface="Open Sans" pitchFamily="34" charset="-122"/>
                 <a:cs typeface="Open Sans" pitchFamily="34" charset="-120"/>
               </a:rPr>
-              <a:t>   ·   03 / 04</a:t>
+              <a:t>   ·   03 / 05</a:t>
             </a:r>
             <a:endParaRPr lang="en-US" sz="1100" dirty="0"/>
           </a:p>
@@ -2653,7 +2732,7 @@
         <p:spPr>
           <a:xfrm>
             <a:off x="640080" y="1280160"/>
-            <a:ext cx="3429000" cy="1104392"/>
+            <a:ext cx="3429000" cy="620776"/>
           </a:xfrm>
           <a:prstGeom prst="rect">
             <a:avLst/>
@@ -2680,7 +2759,7 @@
                 <a:ea typeface="Source Serif Pro" pitchFamily="34" charset="-122"/>
                 <a:cs typeface="Source Serif Pro" pitchFamily="34" charset="-120"/>
               </a:rPr>
-              <a:t>Checklist · Tu sistema</a:t>
+              <a:t>Tu comunidad</a:t>
             </a:r>
             <a:endParaRPr lang="en-US" sz="3400" dirty="0"/>
           </a:p>
@@ -2694,7 +2773,7 @@
         </p:nvSpPr>
         <p:spPr>
           <a:xfrm>
-            <a:off x="640080" y="2521712"/>
+            <a:off x="640080" y="2038096"/>
             <a:ext cx="3291840" cy="640080"/>
           </a:xfrm>
           <a:prstGeom prst="rect">
@@ -2719,7 +2798,7 @@
                 <a:ea typeface="Source Serif Pro" pitchFamily="34" charset="-122"/>
                 <a:cs typeface="Source Serif Pro" pitchFamily="34" charset="-120"/>
               </a:rPr>
-              <a:t>No tiene que estar perfecto, pero sí armado</a:t>
+              <a:t>Para que la uses como parte real de tu proceso</a:t>
             </a:r>
             <a:endParaRPr lang="en-US" sz="1600" dirty="0"/>
           </a:p>
@@ -2734,7 +2813,7 @@
         <p:spPr>
           <a:xfrm>
             <a:off x="4389120" y="1280160"/>
-            <a:ext cx="3451860" cy="914400"/>
+            <a:ext cx="7159752" cy="914400"/>
           </a:xfrm>
           <a:prstGeom prst="roundRect">
             <a:avLst>
@@ -2792,7 +2871,7 @@
         <p:spPr>
           <a:xfrm>
             <a:off x="5212080" y="1280160"/>
-            <a:ext cx="2446020" cy="914400"/>
+            <a:ext cx="6153912" cy="914400"/>
           </a:xfrm>
           <a:prstGeom prst="rect">
             <a:avLst/>
@@ -2808,7 +2887,7 @@
               <a:buNone/>
             </a:pPr>
             <a:r>
-              <a:rPr lang="en-US" sz="1350" dirty="0">
+              <a:rPr lang="en-US" sz="1600" dirty="0">
                 <a:solidFill>
                   <a:srgbClr val="3F1E0D"/>
                 </a:solidFill>
@@ -2816,9 +2895,23 @@
                 <a:ea typeface="Open Sans" pitchFamily="34" charset="-122"/>
                 <a:cs typeface="Open Sans" pitchFamily="34" charset="-120"/>
               </a:rPr>
-              <a:t>¿Abriste tu carpeta personal de AT WORK?</a:t>
-            </a:r>
-            <a:endParaRPr lang="en-US" sz="1350" dirty="0"/>
+              <a:t>Haberte unido a </a:t>
+            </a:r>
+            <a:pPr indent="0" marL="0">
+              <a:buNone/>
+            </a:pPr>
+            <a:r>
+              <a:rPr lang="en-US" sz="1600" b="1" dirty="0">
+                <a:solidFill>
+                  <a:srgbClr val="3F1E0D"/>
+                </a:solidFill>
+                <a:latin typeface="Open Sans" pitchFamily="34" charset="0"/>
+                <a:ea typeface="Open Sans" pitchFamily="34" charset="-122"/>
+                <a:cs typeface="Open Sans" pitchFamily="34" charset="-120"/>
+              </a:rPr>
+              <a:t>AT WORK Community</a:t>
+            </a:r>
+            <a:endParaRPr lang="en-US" sz="1600" dirty="0"/>
           </a:p>
         </p:txBody>
       </p:sp>
@@ -2831,7 +2924,7 @@
         <p:spPr>
           <a:xfrm>
             <a:off x="4389120" y="2377440"/>
-            <a:ext cx="3451860" cy="914400"/>
+            <a:ext cx="7159752" cy="914400"/>
           </a:xfrm>
           <a:prstGeom prst="roundRect">
             <a:avLst>
@@ -2889,7 +2982,7 @@
         <p:spPr>
           <a:xfrm>
             <a:off x="5212080" y="2377440"/>
-            <a:ext cx="2446020" cy="914400"/>
+            <a:ext cx="6153912" cy="914400"/>
           </a:xfrm>
           <a:prstGeom prst="rect">
             <a:avLst/>
@@ -2905,7 +2998,7 @@
               <a:buNone/>
             </a:pPr>
             <a:r>
-              <a:rPr lang="en-US" sz="1350" dirty="0">
+              <a:rPr lang="en-US" sz="1600" dirty="0">
                 <a:solidFill>
                   <a:srgbClr val="3F1E0D"/>
                 </a:solidFill>
@@ -2913,9 +3006,9 @@
                 <a:ea typeface="Open Sans" pitchFamily="34" charset="-122"/>
                 <a:cs typeface="Open Sans" pitchFamily="34" charset="-120"/>
               </a:rPr>
-              <a:t>¿Completaste tu Starting Point?</a:t>
-            </a:r>
-            <a:endParaRPr lang="en-US" sz="1350" dirty="0"/>
+              <a:t>Haberte unido a todos los canales</a:t>
+            </a:r>
+            <a:endParaRPr lang="en-US" sz="1600" dirty="0"/>
           </a:p>
         </p:txBody>
       </p:sp>
@@ -2928,7 +3021,7 @@
         <p:spPr>
           <a:xfrm>
             <a:off x="4389120" y="3474720"/>
-            <a:ext cx="3451860" cy="914400"/>
+            <a:ext cx="7159752" cy="914400"/>
           </a:xfrm>
           <a:prstGeom prst="roundRect">
             <a:avLst>
@@ -2986,7 +3079,7 @@
         <p:spPr>
           <a:xfrm>
             <a:off x="5212080" y="3474720"/>
-            <a:ext cx="2446020" cy="914400"/>
+            <a:ext cx="6153912" cy="914400"/>
           </a:xfrm>
           <a:prstGeom prst="rect">
             <a:avLst/>
@@ -3002,7 +3095,7 @@
               <a:buNone/>
             </a:pPr>
             <a:r>
-              <a:rPr lang="en-US" sz="1350" dirty="0">
+              <a:rPr lang="en-US" sz="1600" dirty="0">
                 <a:solidFill>
                   <a:srgbClr val="3F1E0D"/>
                 </a:solidFill>
@@ -3010,9 +3103,23 @@
                 <a:ea typeface="Open Sans" pitchFamily="34" charset="-122"/>
                 <a:cs typeface="Open Sans" pitchFamily="34" charset="-120"/>
               </a:rPr>
-              <a:t>¿Subiste entre tres y cinco materiales reales de tu trabajo?</a:t>
-            </a:r>
-            <a:endParaRPr lang="en-US" sz="1350" dirty="0"/>
+              <a:t>Haberte presentado en </a:t>
+            </a:r>
+            <a:pPr indent="0" marL="0">
+              <a:buNone/>
+            </a:pPr>
+            <a:r>
+              <a:rPr lang="en-US" sz="1600" b="1" dirty="0">
+                <a:solidFill>
+                  <a:srgbClr val="3F1E0D"/>
+                </a:solidFill>
+                <a:latin typeface="Open Sans" pitchFamily="34" charset="0"/>
+                <a:ea typeface="Open Sans" pitchFamily="34" charset="-122"/>
+                <a:cs typeface="Open Sans" pitchFamily="34" charset="-120"/>
+              </a:rPr>
+              <a:t>Connect &amp; Share</a:t>
+            </a:r>
+            <a:endParaRPr lang="en-US" sz="1600" dirty="0"/>
           </a:p>
         </p:txBody>
       </p:sp>
@@ -3024,7 +3131,342 @@
         </p:nvSpPr>
         <p:spPr>
           <a:xfrm>
-            <a:off x="4389120" y="4572000"/>
+            <a:off x="4389120" y="4983480"/>
+            <a:ext cx="7159752" cy="1371600"/>
+          </a:xfrm>
+          <a:prstGeom prst="roundRect">
+            <a:avLst>
+              <a:gd name="adj" fmla="val 10667"/>
+            </a:avLst>
+          </a:prstGeom>
+          <a:solidFill>
+            <a:srgbClr val="3F1E0D"/>
+          </a:solidFill>
+          <a:ln w="12700">
+            <a:solidFill>
+              <a:srgbClr val="3F1E0D"/>
+            </a:solidFill>
+            <a:prstDash val="solid"/>
+          </a:ln>
+          <a:effectLst>
+            <a:outerShdw sx="100000" sy="100000" kx="0" ky="0" algn="bl" rotWithShape="0" blurRad="177800" dist="38100" dir="5400000">
+              <a:srgbClr val="3F1E0D">
+                <a:alpha val="10000"/>
+              </a:srgbClr>
+            </a:outerShdw>
+          </a:effectLst>
+        </p:spPr>
+      </p:sp>
+      <p:sp>
+        <p:nvSpPr>
+          <p:cNvPr id="17" name="Shape 10"/>
+          <p:cNvSpPr/>
+          <p:nvPr/>
+        </p:nvSpPr>
+        <p:spPr>
+          <a:xfrm>
+            <a:off x="4754880" y="5280660"/>
+            <a:ext cx="777240" cy="777240"/>
+          </a:xfrm>
+          <a:prstGeom prst="ellipse">
+            <a:avLst/>
+          </a:prstGeom>
+          <a:solidFill>
+            <a:srgbClr val="C68C6C"/>
+          </a:solidFill>
+          <a:ln w="12700">
+            <a:solidFill>
+              <a:srgbClr val="C68C6C"/>
+            </a:solidFill>
+            <a:prstDash val="solid"/>
+          </a:ln>
+        </p:spPr>
+      </p:sp>
+      <p:pic>
+        <p:nvPicPr>
+          <p:cNvPr id="18" name="Image 4" descr="preencoded.png">    </p:cNvPr>
+          <p:cNvPicPr>
+            <a:picLocks noChangeAspect="1"/>
+          </p:cNvPicPr>
+          <p:nvPr/>
+        </p:nvPicPr>
+        <p:blipFill>
+          <a:blip r:embed="rId5"/>
+          <a:stretch>
+            <a:fillRect/>
+          </a:stretch>
+        </p:blipFill>
+        <p:spPr>
+          <a:xfrm>
+            <a:off x="4964735" y="5490515"/>
+            <a:ext cx="357530" cy="357530"/>
+          </a:xfrm>
+          <a:prstGeom prst="rect">
+            <a:avLst/>
+          </a:prstGeom>
+        </p:spPr>
+      </p:pic>
+      <p:sp>
+        <p:nvSpPr>
+          <p:cNvPr id="19" name="Text 11"/>
+          <p:cNvSpPr txBox="1"/>
+          <p:nvPr/>
+        </p:nvSpPr>
+        <p:spPr>
+          <a:xfrm>
+            <a:off x="5852160" y="4983480"/>
+            <a:ext cx="5376672" cy="1371600"/>
+          </a:xfrm>
+          <a:prstGeom prst="rect">
+            <a:avLst/>
+          </a:prstGeom>
+          <a:noFill/>
+          <a:ln/>
+        </p:spPr>
+        <p:txBody>
+          <a:bodyPr wrap="square" lIns="0" tIns="0" rIns="0" bIns="0" rtlCol="0" anchor="ctr"/>
+          <a:lstStyle/>
+          <a:p>
+            <a:pPr indent="0" marL="0">
+              <a:spcAft>
+                <a:spcPts val="500"/>
+              </a:spcAft>
+              <a:buNone/>
+            </a:pPr>
+            <a:r>
+              <a:rPr lang="en-US" sz="1700" b="1" dirty="0">
+                <a:solidFill>
+                  <a:srgbClr val="F8F5EE"/>
+                </a:solidFill>
+                <a:latin typeface="Open Sans" pitchFamily="34" charset="0"/>
+                <a:ea typeface="Open Sans" pitchFamily="34" charset="-122"/>
+                <a:cs typeface="Open Sans" pitchFamily="34" charset="-120"/>
+              </a:rPr>
+              <a:t>Los canales</a:t>
+            </a:r>
+            <a:endParaRPr lang="en-US" sz="1700" dirty="0"/>
+          </a:p>
+          <a:p>
+            <a:pPr indent="0" marL="0">
+              <a:spcAft>
+                <a:spcPts val="500"/>
+              </a:spcAft>
+              <a:buNone/>
+            </a:pPr>
+            <a:r>
+              <a:rPr lang="en-US" sz="1600" dirty="0">
+                <a:solidFill>
+                  <a:srgbClr val="EDE5CC"/>
+                </a:solidFill>
+                <a:latin typeface="Open Sans" pitchFamily="34" charset="0"/>
+                <a:ea typeface="Open Sans" pitchFamily="34" charset="-122"/>
+                <a:cs typeface="Open Sans" pitchFamily="34" charset="-120"/>
+              </a:rPr>
+              <a:t>Announcements · Weekly Reports · Wins · Questions &amp; Support · Connect &amp; Share</a:t>
+            </a:r>
+            <a:endParaRPr lang="en-US" sz="1700" dirty="0"/>
+          </a:p>
+        </p:txBody>
+      </p:sp>
+    </p:spTree>
+  </p:cSld>
+  <p:clrMapOvr>
+    <a:masterClrMapping/>
+  </p:clrMapOvr>
+</p:sld>
+</file>
+
+<file path=ppt/slides/slide4.xml><?xml version="1.0" encoding="utf-8"?>
+<p:sld xmlns:a="http://schemas.openxmlformats.org/drawingml/2006/main" xmlns:r="http://schemas.openxmlformats.org/officeDocument/2006/relationships" xmlns:p="http://schemas.openxmlformats.org/presentationml/2006/main">
+  <p:cSld name="Slide 4">
+    <p:bg>
+      <p:bgPr>
+        <a:solidFill>
+          <a:srgbClr val="F8F5EE"/>
+        </a:solidFill>
+      </p:bgPr>
+    </p:bg>
+    <p:spTree>
+      <p:nvGrpSpPr>
+        <p:cNvPr id="1" name=""/>
+        <p:cNvGrpSpPr/>
+        <p:nvPr/>
+      </p:nvGrpSpPr>
+      <p:grpSpPr>
+        <a:xfrm>
+          <a:off x="0" y="0"/>
+          <a:ext cx="0" cy="0"/>
+          <a:chOff x="0" y="0"/>
+          <a:chExt cx="0" cy="0"/>
+        </a:xfrm>
+      </p:grpSpPr>
+      <p:pic>
+        <p:nvPicPr>
+          <p:cNvPr id="3" name="Image 0" descr="Breaking Barriers at work">    </p:cNvPr>
+          <p:cNvPicPr>
+            <a:picLocks noChangeAspect="1"/>
+          </p:cNvPicPr>
+          <p:nvPr/>
+        </p:nvPicPr>
+        <p:blipFill>
+          <a:blip r:embed="rId1"/>
+          <a:stretch>
+            <a:fillRect/>
+          </a:stretch>
+        </p:blipFill>
+        <p:spPr>
+          <a:xfrm>
+            <a:off x="640080" y="274320"/>
+            <a:ext cx="1188720" cy="542536"/>
+          </a:xfrm>
+          <a:prstGeom prst="rect">
+            <a:avLst/>
+          </a:prstGeom>
+        </p:spPr>
+      </p:pic>
+      <p:sp>
+        <p:nvSpPr>
+          <p:cNvPr id="4" name="Text 0"/>
+          <p:cNvSpPr txBox="1"/>
+          <p:nvPr/>
+        </p:nvSpPr>
+        <p:spPr>
+          <a:xfrm>
+            <a:off x="7891272" y="384048"/>
+            <a:ext cx="3657600" cy="274320"/>
+          </a:xfrm>
+          <a:prstGeom prst="rect">
+            <a:avLst/>
+          </a:prstGeom>
+          <a:noFill/>
+          <a:ln/>
+        </p:spPr>
+        <p:txBody>
+          <a:bodyPr wrap="square" lIns="0" tIns="0" rIns="0" bIns="0" rtlCol="0" anchor="ctr"/>
+          <a:lstStyle/>
+          <a:p>
+            <a:pPr algn="r" indent="0" marL="0">
+              <a:buNone/>
+            </a:pPr>
+            <a:r>
+              <a:rPr lang="en-US" sz="1100" i="1" dirty="0">
+                <a:solidFill>
+                  <a:srgbClr val="8A6A55"/>
+                </a:solidFill>
+                <a:latin typeface="Source Serif Pro" pitchFamily="34" charset="0"/>
+                <a:ea typeface="Source Serif Pro" pitchFamily="34" charset="-122"/>
+                <a:cs typeface="Source Serif Pro" pitchFamily="34" charset="-120"/>
+              </a:rPr>
+              <a:t>by Flor Pérsico</a:t>
+            </a:r>
+            <a:pPr algn="r" indent="0" marL="0">
+              <a:buNone/>
+            </a:pPr>
+            <a:r>
+              <a:rPr lang="en-US" sz="1100" dirty="0">
+                <a:solidFill>
+                  <a:srgbClr val="8A6A55"/>
+                </a:solidFill>
+                <a:latin typeface="Open Sans" pitchFamily="34" charset="0"/>
+                <a:ea typeface="Open Sans" pitchFamily="34" charset="-122"/>
+                <a:cs typeface="Open Sans" pitchFamily="34" charset="-120"/>
+              </a:rPr>
+              <a:t>   ·   04 / 05</a:t>
+            </a:r>
+            <a:endParaRPr lang="en-US" sz="1100" dirty="0"/>
+          </a:p>
+        </p:txBody>
+      </p:sp>
+      <p:sp>
+        <p:nvSpPr>
+          <p:cNvPr id="5" name="Text 1"/>
+          <p:cNvSpPr txBox="1"/>
+          <p:nvPr/>
+        </p:nvSpPr>
+        <p:spPr>
+          <a:xfrm>
+            <a:off x="640080" y="1280160"/>
+            <a:ext cx="3429000" cy="1104392"/>
+          </a:xfrm>
+          <a:prstGeom prst="rect">
+            <a:avLst/>
+          </a:prstGeom>
+          <a:noFill/>
+          <a:ln/>
+        </p:spPr>
+        <p:txBody>
+          <a:bodyPr wrap="square" lIns="0" tIns="0" rIns="0" bIns="0" rtlCol="0" anchor="t"/>
+          <a:lstStyle/>
+          <a:p>
+            <a:pPr indent="0" marL="0">
+              <a:lnSpc>
+                <a:spcPct val="92000"/>
+              </a:lnSpc>
+              <a:buNone/>
+            </a:pPr>
+            <a:r>
+              <a:rPr lang="en-US" sz="3400" b="1" dirty="0">
+                <a:solidFill>
+                  <a:srgbClr val="81552E"/>
+                </a:solidFill>
+                <a:latin typeface="Source Serif Pro" pitchFamily="34" charset="0"/>
+                <a:ea typeface="Source Serif Pro" pitchFamily="34" charset="-122"/>
+                <a:cs typeface="Source Serif Pro" pitchFamily="34" charset="-120"/>
+              </a:rPr>
+              <a:t>Tu sistema de trabajo</a:t>
+            </a:r>
+            <a:endParaRPr lang="en-US" sz="3400" dirty="0"/>
+          </a:p>
+        </p:txBody>
+      </p:sp>
+      <p:sp>
+        <p:nvSpPr>
+          <p:cNvPr id="6" name="Text 2"/>
+          <p:cNvSpPr txBox="1"/>
+          <p:nvPr/>
+        </p:nvSpPr>
+        <p:spPr>
+          <a:xfrm>
+            <a:off x="640080" y="2521712"/>
+            <a:ext cx="3291840" cy="640080"/>
+          </a:xfrm>
+          <a:prstGeom prst="rect">
+            <a:avLst/>
+          </a:prstGeom>
+          <a:noFill/>
+          <a:ln/>
+        </p:spPr>
+        <p:txBody>
+          <a:bodyPr wrap="square" lIns="0" tIns="0" rIns="0" bIns="0" rtlCol="0" anchor="t"/>
+          <a:lstStyle/>
+          <a:p>
+            <a:pPr indent="0" marL="0">
+              <a:buNone/>
+            </a:pPr>
+            <a:r>
+              <a:rPr lang="en-US" sz="1600" i="1" dirty="0">
+                <a:solidFill>
+                  <a:srgbClr val="8A6A55"/>
+                </a:solidFill>
+                <a:latin typeface="Source Serif Pro" pitchFamily="34" charset="0"/>
+                <a:ea typeface="Source Serif Pro" pitchFamily="34" charset="-122"/>
+                <a:cs typeface="Source Serif Pro" pitchFamily="34" charset="-120"/>
+              </a:rPr>
+              <a:t>No necesitas tenerlo todo resuelto, pero sí saber desde dónde partes</a:t>
+            </a:r>
+            <a:endParaRPr lang="en-US" sz="1600" dirty="0"/>
+          </a:p>
+        </p:txBody>
+      </p:sp>
+      <p:sp>
+        <p:nvSpPr>
+          <p:cNvPr id="7" name="Shape 3"/>
+          <p:cNvSpPr/>
+          <p:nvPr/>
+        </p:nvSpPr>
+        <p:spPr>
+          <a:xfrm>
+            <a:off x="4389120" y="1280160"/>
             <a:ext cx="3451860" cy="914400"/>
           </a:xfrm>
           <a:prstGeom prst="roundRect">
@@ -3052,21 +3494,21 @@
       </p:sp>
       <p:pic>
         <p:nvPicPr>
-          <p:cNvPr id="17" name="Image 4" descr="preencoded.png">    </p:cNvPr>
+          <p:cNvPr id="8" name="Image 1" descr="preencoded.png">    </p:cNvPr>
           <p:cNvPicPr>
             <a:picLocks noChangeAspect="1"/>
           </p:cNvPicPr>
           <p:nvPr/>
         </p:nvPicPr>
         <p:blipFill>
-          <a:blip r:embed="rId5"/>
+          <a:blip r:embed="rId2"/>
           <a:stretch>
             <a:fillRect/>
           </a:stretch>
         </p:blipFill>
         <p:spPr>
           <a:xfrm>
-            <a:off x="4663440" y="4855464"/>
+            <a:off x="4663440" y="1563624"/>
             <a:ext cx="347472" cy="347472"/>
           </a:xfrm>
           <a:prstGeom prst="rect">
@@ -3076,13 +3518,13 @@
       </p:pic>
       <p:sp>
         <p:nvSpPr>
-          <p:cNvPr id="18" name="Text 10"/>
+          <p:cNvPr id="9" name="Text 4"/>
           <p:cNvSpPr txBox="1"/>
           <p:nvPr/>
         </p:nvSpPr>
         <p:spPr>
           <a:xfrm>
-            <a:off x="5212080" y="4572000"/>
+            <a:off x="5212080" y="1280160"/>
             <a:ext cx="2446020" cy="914400"/>
           </a:xfrm>
           <a:prstGeom prst="rect">
@@ -3099,7 +3541,7 @@
               <a:buNone/>
             </a:pPr>
             <a:r>
-              <a:rPr lang="en-US" sz="1350" dirty="0">
+              <a:rPr lang="en-US" sz="1400" dirty="0">
                 <a:solidFill>
                   <a:srgbClr val="3F1E0D"/>
                 </a:solidFill>
@@ -3107,21 +3549,21 @@
                 <a:ea typeface="Open Sans" pitchFamily="34" charset="-122"/>
                 <a:cs typeface="Open Sans" pitchFamily="34" charset="-120"/>
               </a:rPr>
-              <a:t>¿Reservaste tus bloques semanales de práctica?</a:t>
-            </a:r>
-            <a:endParaRPr lang="en-US" sz="1350" dirty="0"/>
-          </a:p>
-        </p:txBody>
-      </p:sp>
-      <p:sp>
-        <p:nvSpPr>
-          <p:cNvPr id="19" name="Shape 11"/>
+              <a:t>Haber abierto y ubicado tu carpeta personal de AT WORK</a:t>
+            </a:r>
+            <a:endParaRPr lang="en-US" sz="1400" dirty="0"/>
+          </a:p>
+        </p:txBody>
+      </p:sp>
+      <p:sp>
+        <p:nvSpPr>
+          <p:cNvPr id="10" name="Shape 5"/>
           <p:cNvSpPr/>
           <p:nvPr/>
         </p:nvSpPr>
         <p:spPr>
           <a:xfrm>
-            <a:off x="8097012" y="1280160"/>
+            <a:off x="4389120" y="2377440"/>
             <a:ext cx="3451860" cy="914400"/>
           </a:xfrm>
           <a:prstGeom prst="roundRect">
@@ -3149,21 +3591,21 @@
       </p:sp>
       <p:pic>
         <p:nvPicPr>
-          <p:cNvPr id="20" name="Image 5" descr="preencoded.png">    </p:cNvPr>
+          <p:cNvPr id="11" name="Image 2" descr="preencoded.png">    </p:cNvPr>
           <p:cNvPicPr>
             <a:picLocks noChangeAspect="1"/>
           </p:cNvPicPr>
           <p:nvPr/>
         </p:nvPicPr>
         <p:blipFill>
-          <a:blip r:embed="rId6"/>
+          <a:blip r:embed="rId3"/>
           <a:stretch>
             <a:fillRect/>
           </a:stretch>
         </p:blipFill>
         <p:spPr>
           <a:xfrm>
-            <a:off x="8371332" y="1563624"/>
+            <a:off x="4663440" y="2660904"/>
             <a:ext cx="347472" cy="347472"/>
           </a:xfrm>
           <a:prstGeom prst="rect">
@@ -3173,13 +3615,13 @@
       </p:pic>
       <p:sp>
         <p:nvSpPr>
-          <p:cNvPr id="21" name="Text 12"/>
+          <p:cNvPr id="12" name="Text 6"/>
           <p:cNvSpPr txBox="1"/>
           <p:nvPr/>
         </p:nvSpPr>
         <p:spPr>
           <a:xfrm>
-            <a:off x="8919972" y="1280160"/>
+            <a:off x="5212080" y="2377440"/>
             <a:ext cx="2446020" cy="914400"/>
           </a:xfrm>
           <a:prstGeom prst="rect">
@@ -3196,7 +3638,7 @@
               <a:buNone/>
             </a:pPr>
             <a:r>
-              <a:rPr lang="en-US" sz="1350" dirty="0">
+              <a:rPr lang="en-US" sz="1400" dirty="0">
                 <a:solidFill>
                   <a:srgbClr val="3F1E0D"/>
                 </a:solidFill>
@@ -3204,21 +3646,21 @@
                 <a:ea typeface="Open Sans" pitchFamily="34" charset="-122"/>
                 <a:cs typeface="Open Sans" pitchFamily="34" charset="-120"/>
               </a:rPr>
-              <a:t>¿Sabes dónde pedir feedback y qué incluir?</a:t>
-            </a:r>
-            <a:endParaRPr lang="en-US" sz="1350" dirty="0"/>
-          </a:p>
-        </p:txBody>
-      </p:sp>
-      <p:sp>
-        <p:nvSpPr>
-          <p:cNvPr id="22" name="Shape 13"/>
+              <a:t>Haber subido 3–5 materiales reales de tu trabajo</a:t>
+            </a:r>
+            <a:endParaRPr lang="en-US" sz="1400" dirty="0"/>
+          </a:p>
+        </p:txBody>
+      </p:sp>
+      <p:sp>
+        <p:nvSpPr>
+          <p:cNvPr id="13" name="Shape 7"/>
           <p:cNvSpPr/>
           <p:nvPr/>
         </p:nvSpPr>
         <p:spPr>
           <a:xfrm>
-            <a:off x="8097012" y="2377440"/>
+            <a:off x="4389120" y="3474720"/>
             <a:ext cx="3451860" cy="914400"/>
           </a:xfrm>
           <a:prstGeom prst="roundRect">
@@ -3246,21 +3688,21 @@
       </p:sp>
       <p:pic>
         <p:nvPicPr>
-          <p:cNvPr id="23" name="Image 6" descr="preencoded.png">    </p:cNvPr>
+          <p:cNvPr id="14" name="Image 3" descr="preencoded.png">    </p:cNvPr>
           <p:cNvPicPr>
             <a:picLocks noChangeAspect="1"/>
           </p:cNvPicPr>
           <p:nvPr/>
         </p:nvPicPr>
         <p:blipFill>
-          <a:blip r:embed="rId7"/>
+          <a:blip r:embed="rId4"/>
           <a:stretch>
             <a:fillRect/>
           </a:stretch>
         </p:blipFill>
         <p:spPr>
           <a:xfrm>
-            <a:off x="8371332" y="2660904"/>
+            <a:off x="4663440" y="3758184"/>
             <a:ext cx="347472" cy="347472"/>
           </a:xfrm>
           <a:prstGeom prst="rect">
@@ -3270,13 +3712,13 @@
       </p:pic>
       <p:sp>
         <p:nvSpPr>
-          <p:cNvPr id="24" name="Text 14"/>
+          <p:cNvPr id="15" name="Text 8"/>
           <p:cNvSpPr txBox="1"/>
           <p:nvPr/>
         </p:nvSpPr>
         <p:spPr>
           <a:xfrm>
-            <a:off x="8919972" y="2377440"/>
+            <a:off x="5212080" y="3474720"/>
             <a:ext cx="2446020" cy="914400"/>
           </a:xfrm>
           <a:prstGeom prst="rect">
@@ -3293,7 +3735,7 @@
               <a:buNone/>
             </a:pPr>
             <a:r>
-              <a:rPr lang="en-US" sz="1350" dirty="0">
+              <a:rPr lang="en-US" sz="1400" dirty="0">
                 <a:solidFill>
                   <a:srgbClr val="3F1E0D"/>
                 </a:solidFill>
@@ -3301,21 +3743,21 @@
                 <a:ea typeface="Open Sans" pitchFamily="34" charset="-122"/>
                 <a:cs typeface="Open Sans" pitchFamily="34" charset="-120"/>
               </a:rPr>
-              <a:t>¿Sabes que cada semana completas tu Weekly Report y lo guardas en tu Drive?</a:t>
-            </a:r>
-            <a:endParaRPr lang="en-US" sz="1350" dirty="0"/>
-          </a:p>
-        </p:txBody>
-      </p:sp>
-      <p:sp>
-        <p:nvSpPr>
-          <p:cNvPr id="25" name="Shape 15"/>
+              <a:t>Haber reservado tus bloques semanales de práctica</a:t>
+            </a:r>
+            <a:endParaRPr lang="en-US" sz="1400" dirty="0"/>
+          </a:p>
+        </p:txBody>
+      </p:sp>
+      <p:sp>
+        <p:nvSpPr>
+          <p:cNvPr id="16" name="Shape 9"/>
           <p:cNvSpPr/>
           <p:nvPr/>
         </p:nvSpPr>
         <p:spPr>
           <a:xfrm>
-            <a:off x="8097012" y="3474720"/>
+            <a:off x="8097012" y="1280160"/>
             <a:ext cx="3451860" cy="914400"/>
           </a:xfrm>
           <a:prstGeom prst="roundRect">
@@ -3343,21 +3785,21 @@
       </p:sp>
       <p:pic>
         <p:nvPicPr>
-          <p:cNvPr id="26" name="Image 7" descr="preencoded.png">    </p:cNvPr>
+          <p:cNvPr id="17" name="Image 4" descr="preencoded.png">    </p:cNvPr>
           <p:cNvPicPr>
             <a:picLocks noChangeAspect="1"/>
           </p:cNvPicPr>
           <p:nvPr/>
         </p:nvPicPr>
         <p:blipFill>
-          <a:blip r:embed="rId8"/>
+          <a:blip r:embed="rId5"/>
           <a:stretch>
             <a:fillRect/>
           </a:stretch>
         </p:blipFill>
         <p:spPr>
           <a:xfrm>
-            <a:off x="8371332" y="3758184"/>
+            <a:off x="8371332" y="1563624"/>
             <a:ext cx="347472" cy="347472"/>
           </a:xfrm>
           <a:prstGeom prst="rect">
@@ -3367,13 +3809,13 @@
       </p:pic>
       <p:sp>
         <p:nvSpPr>
-          <p:cNvPr id="27" name="Text 16"/>
+          <p:cNvPr id="18" name="Text 10"/>
           <p:cNvSpPr txBox="1"/>
           <p:nvPr/>
         </p:nvSpPr>
         <p:spPr>
           <a:xfrm>
-            <a:off x="8919972" y="3474720"/>
+            <a:off x="8919972" y="1280160"/>
             <a:ext cx="2446020" cy="914400"/>
           </a:xfrm>
           <a:prstGeom prst="rect">
@@ -3390,7 +3832,7 @@
               <a:buNone/>
             </a:pPr>
             <a:r>
-              <a:rPr lang="en-US" sz="1350" dirty="0">
+              <a:rPr lang="en-US" sz="1400" dirty="0">
                 <a:solidFill>
                   <a:srgbClr val="3F1E0D"/>
                 </a:solidFill>
@@ -3398,9 +3840,217 @@
                 <a:ea typeface="Open Sans" pitchFamily="34" charset="-122"/>
                 <a:cs typeface="Open Sans" pitchFamily="34" charset="-120"/>
               </a:rPr>
-              <a:t>¿Tienes claro tu foco actual?</a:t>
-            </a:r>
-            <a:endParaRPr lang="en-US" sz="1350" dirty="0"/>
+              <a:t>Saber dónde y cómo pedir feedback</a:t>
+            </a:r>
+            <a:endParaRPr lang="en-US" sz="1400" dirty="0"/>
+          </a:p>
+        </p:txBody>
+      </p:sp>
+      <p:sp>
+        <p:nvSpPr>
+          <p:cNvPr id="19" name="Shape 11"/>
+          <p:cNvSpPr/>
+          <p:nvPr/>
+        </p:nvSpPr>
+        <p:spPr>
+          <a:xfrm>
+            <a:off x="8097012" y="2377440"/>
+            <a:ext cx="3451860" cy="914400"/>
+          </a:xfrm>
+          <a:prstGeom prst="roundRect">
+            <a:avLst>
+              <a:gd name="adj" fmla="val 16000"/>
+            </a:avLst>
+          </a:prstGeom>
+          <a:solidFill>
+            <a:srgbClr val="FFFDF9"/>
+          </a:solidFill>
+          <a:ln w="12700">
+            <a:solidFill>
+              <a:srgbClr val="FFFDF9"/>
+            </a:solidFill>
+            <a:prstDash val="solid"/>
+          </a:ln>
+          <a:effectLst>
+            <a:outerShdw sx="100000" sy="100000" kx="0" ky="0" algn="bl" rotWithShape="0" blurRad="177800" dist="38100" dir="5400000">
+              <a:srgbClr val="3F1E0D">
+                <a:alpha val="10000"/>
+              </a:srgbClr>
+            </a:outerShdw>
+          </a:effectLst>
+        </p:spPr>
+      </p:sp>
+      <p:pic>
+        <p:nvPicPr>
+          <p:cNvPr id="20" name="Image 5" descr="preencoded.png">    </p:cNvPr>
+          <p:cNvPicPr>
+            <a:picLocks noChangeAspect="1"/>
+          </p:cNvPicPr>
+          <p:nvPr/>
+        </p:nvPicPr>
+        <p:blipFill>
+          <a:blip r:embed="rId6"/>
+          <a:stretch>
+            <a:fillRect/>
+          </a:stretch>
+        </p:blipFill>
+        <p:spPr>
+          <a:xfrm>
+            <a:off x="8371332" y="2660904"/>
+            <a:ext cx="347472" cy="347472"/>
+          </a:xfrm>
+          <a:prstGeom prst="rect">
+            <a:avLst/>
+          </a:prstGeom>
+        </p:spPr>
+      </p:pic>
+      <p:sp>
+        <p:nvSpPr>
+          <p:cNvPr id="21" name="Text 12"/>
+          <p:cNvSpPr txBox="1"/>
+          <p:nvPr/>
+        </p:nvSpPr>
+        <p:spPr>
+          <a:xfrm>
+            <a:off x="8919972" y="2377440"/>
+            <a:ext cx="2446020" cy="914400"/>
+          </a:xfrm>
+          <a:prstGeom prst="rect">
+            <a:avLst/>
+          </a:prstGeom>
+          <a:noFill/>
+          <a:ln/>
+        </p:spPr>
+        <p:txBody>
+          <a:bodyPr wrap="square" lIns="0" tIns="0" rIns="0" bIns="0" rtlCol="0" anchor="ctr"/>
+          <a:lstStyle/>
+          <a:p>
+            <a:pPr indent="0" marL="0">
+              <a:buNone/>
+            </a:pPr>
+            <a:r>
+              <a:rPr lang="en-US" sz="1400" dirty="0">
+                <a:solidFill>
+                  <a:srgbClr val="3F1E0D"/>
+                </a:solidFill>
+                <a:latin typeface="Open Sans" pitchFamily="34" charset="0"/>
+                <a:ea typeface="Open Sans" pitchFamily="34" charset="-122"/>
+                <a:cs typeface="Open Sans" pitchFamily="34" charset="-120"/>
+              </a:rPr>
+              <a:t>Tener claro cómo funciona el Weekly Report y dónde guardarlo</a:t>
+            </a:r>
+            <a:endParaRPr lang="en-US" sz="1400" dirty="0"/>
+          </a:p>
+        </p:txBody>
+      </p:sp>
+      <p:sp>
+        <p:nvSpPr>
+          <p:cNvPr id="22" name="Shape 13"/>
+          <p:cNvSpPr/>
+          <p:nvPr/>
+        </p:nvSpPr>
+        <p:spPr>
+          <a:xfrm>
+            <a:off x="8097012" y="3474720"/>
+            <a:ext cx="3451860" cy="914400"/>
+          </a:xfrm>
+          <a:prstGeom prst="roundRect">
+            <a:avLst>
+              <a:gd name="adj" fmla="val 16000"/>
+            </a:avLst>
+          </a:prstGeom>
+          <a:solidFill>
+            <a:srgbClr val="FFFDF9"/>
+          </a:solidFill>
+          <a:ln w="12700">
+            <a:solidFill>
+              <a:srgbClr val="FFFDF9"/>
+            </a:solidFill>
+            <a:prstDash val="solid"/>
+          </a:ln>
+          <a:effectLst>
+            <a:outerShdw sx="100000" sy="100000" kx="0" ky="0" algn="bl" rotWithShape="0" blurRad="177800" dist="38100" dir="5400000">
+              <a:srgbClr val="3F1E0D">
+                <a:alpha val="10000"/>
+              </a:srgbClr>
+            </a:outerShdw>
+          </a:effectLst>
+        </p:spPr>
+      </p:sp>
+      <p:pic>
+        <p:nvPicPr>
+          <p:cNvPr id="23" name="Image 6" descr="preencoded.png">    </p:cNvPr>
+          <p:cNvPicPr>
+            <a:picLocks noChangeAspect="1"/>
+          </p:cNvPicPr>
+          <p:nvPr/>
+        </p:nvPicPr>
+        <p:blipFill>
+          <a:blip r:embed="rId7"/>
+          <a:stretch>
+            <a:fillRect/>
+          </a:stretch>
+        </p:blipFill>
+        <p:spPr>
+          <a:xfrm>
+            <a:off x="8371332" y="3758184"/>
+            <a:ext cx="347472" cy="347472"/>
+          </a:xfrm>
+          <a:prstGeom prst="rect">
+            <a:avLst/>
+          </a:prstGeom>
+        </p:spPr>
+      </p:pic>
+      <p:sp>
+        <p:nvSpPr>
+          <p:cNvPr id="24" name="Text 14"/>
+          <p:cNvSpPr txBox="1"/>
+          <p:nvPr/>
+        </p:nvSpPr>
+        <p:spPr>
+          <a:xfrm>
+            <a:off x="8919972" y="3474720"/>
+            <a:ext cx="2446020" cy="914400"/>
+          </a:xfrm>
+          <a:prstGeom prst="rect">
+            <a:avLst/>
+          </a:prstGeom>
+          <a:noFill/>
+          <a:ln/>
+        </p:spPr>
+        <p:txBody>
+          <a:bodyPr wrap="square" lIns="0" tIns="0" rIns="0" bIns="0" rtlCol="0" anchor="ctr"/>
+          <a:lstStyle/>
+          <a:p>
+            <a:pPr indent="0" marL="0">
+              <a:buNone/>
+            </a:pPr>
+            <a:r>
+              <a:rPr lang="en-US" sz="1400" dirty="0">
+                <a:solidFill>
+                  <a:srgbClr val="3F1E0D"/>
+                </a:solidFill>
+                <a:latin typeface="Open Sans" pitchFamily="34" charset="0"/>
+                <a:ea typeface="Open Sans" pitchFamily="34" charset="-122"/>
+                <a:cs typeface="Open Sans" pitchFamily="34" charset="-120"/>
+              </a:rPr>
+              <a:t>Tener claro tu </a:t>
+            </a:r>
+            <a:pPr indent="0" marL="0">
+              <a:buNone/>
+            </a:pPr>
+            <a:r>
+              <a:rPr lang="en-US" sz="1400" b="1" dirty="0">
+                <a:solidFill>
+                  <a:srgbClr val="3F1E0D"/>
+                </a:solidFill>
+                <a:latin typeface="Open Sans" pitchFamily="34" charset="0"/>
+                <a:ea typeface="Open Sans" pitchFamily="34" charset="-122"/>
+                <a:cs typeface="Open Sans" pitchFamily="34" charset="-120"/>
+              </a:rPr>
+              <a:t>foco inicial</a:t>
+            </a:r>
+            <a:endParaRPr lang="en-US" sz="1400" dirty="0"/>
           </a:p>
         </p:txBody>
       </p:sp>
@@ -3412,9 +4062,9 @@
 </p:sld>
 </file>
 
-<file path=ppt/slides/slide4.xml><?xml version="1.0" encoding="utf-8"?>
+<file path=ppt/slides/slide5.xml><?xml version="1.0" encoding="utf-8"?>
 <p:sld xmlns:a="http://schemas.openxmlformats.org/drawingml/2006/main" xmlns:r="http://schemas.openxmlformats.org/officeDocument/2006/relationships" xmlns:p="http://schemas.openxmlformats.org/presentationml/2006/main">
-  <p:cSld name="Slide 4">
+  <p:cSld name="Slide 5">
     <p:bg>
       <p:bgPr>
         <a:solidFill>
@@ -3507,7 +4157,7 @@
                 <a:ea typeface="Open Sans" pitchFamily="34" charset="-122"/>
                 <a:cs typeface="Open Sans" pitchFamily="34" charset="-120"/>
               </a:rPr>
-              <a:t>   ·   04 / 04</a:t>
+              <a:t>   ·   05 / 05</a:t>
             </a:r>
             <a:endParaRPr lang="en-US" sz="1100" dirty="0"/>
           </a:p>
@@ -3522,7 +4172,7 @@
         <p:spPr>
           <a:xfrm>
             <a:off x="640080" y="1280160"/>
-            <a:ext cx="3429000" cy="1588008"/>
+            <a:ext cx="3429000" cy="620776"/>
           </a:xfrm>
           <a:prstGeom prst="rect">
             <a:avLst/>
@@ -3549,7 +4199,7 @@
                 <a:ea typeface="Source Serif Pro" pitchFamily="34" charset="-122"/>
                 <a:cs typeface="Source Serif Pro" pitchFamily="34" charset="-120"/>
               </a:rPr>
-              <a:t>Ya puedes empezar el Módulo 1</a:t>
+              <a:t>Último paso</a:t>
             </a:r>
             <a:endParaRPr lang="en-US" sz="3400" dirty="0"/>
           </a:p>
@@ -3563,8 +4213,8 @@
         </p:nvSpPr>
         <p:spPr>
           <a:xfrm>
-            <a:off x="640080" y="3005328"/>
-            <a:ext cx="3291840" cy="365760"/>
+            <a:off x="640080" y="2038096"/>
+            <a:ext cx="3291840" cy="640080"/>
           </a:xfrm>
           <a:prstGeom prst="rect">
             <a:avLst/>
@@ -3588,7 +4238,7 @@
                 <a:ea typeface="Source Serif Pro" pitchFamily="34" charset="-122"/>
                 <a:cs typeface="Source Serif Pro" pitchFamily="34" charset="-120"/>
               </a:rPr>
-              <a:t>Activate Your English</a:t>
+              <a:t>Cuando todo esté listo, tu onboarding está completo</a:t>
             </a:r>
             <a:endParaRPr lang="en-US" sz="1600" dirty="0"/>
           </a:p>
@@ -3603,11 +4253,11 @@
         <p:spPr>
           <a:xfrm>
             <a:off x="4389120" y="1280160"/>
-            <a:ext cx="7159752" cy="946404"/>
+            <a:ext cx="7159752" cy="1097280"/>
           </a:xfrm>
           <a:prstGeom prst="roundRect">
             <a:avLst>
-              <a:gd name="adj" fmla="val 15459"/>
+              <a:gd name="adj" fmla="val 13333"/>
             </a:avLst>
           </a:prstGeom>
           <a:solidFill>
@@ -3636,7 +4286,7 @@
         </p:nvSpPr>
         <p:spPr>
           <a:xfrm>
-            <a:off x="4709160" y="1451610"/>
+            <a:off x="4709160" y="1527048"/>
             <a:ext cx="603504" cy="603504"/>
           </a:xfrm>
           <a:prstGeom prst="ellipse">
@@ -3669,7 +4319,7 @@
         </p:blipFill>
         <p:spPr>
           <a:xfrm>
-            <a:off x="4872106" y="1614556"/>
+            <a:off x="4872106" y="1689994"/>
             <a:ext cx="277612" cy="277612"/>
           </a:xfrm>
           <a:prstGeom prst="rect">
@@ -3686,7 +4336,7 @@
         <p:spPr>
           <a:xfrm>
             <a:off x="5577840" y="1280160"/>
-            <a:ext cx="5696712" cy="946404"/>
+            <a:ext cx="5696712" cy="1097280"/>
           </a:xfrm>
           <a:prstGeom prst="rect">
             <a:avLst/>
@@ -3710,21 +4360,7 @@
                 <a:ea typeface="Open Sans" pitchFamily="34" charset="-122"/>
                 <a:cs typeface="Open Sans" pitchFamily="34" charset="-120"/>
               </a:rPr>
-              <a:t>Sigue el foco de cada semana</a:t>
-            </a:r>
-            <a:pPr indent="0" marL="0">
-              <a:buNone/>
-            </a:pPr>
-            <a:r>
-              <a:rPr lang="en-US" sz="1650" dirty="0">
-                <a:solidFill>
-                  <a:srgbClr val="3F1E0D"/>
-                </a:solidFill>
-                <a:latin typeface="Open Sans" pitchFamily="34" charset="0"/>
-                <a:ea typeface="Open Sans" pitchFamily="34" charset="-122"/>
-                <a:cs typeface="Open Sans" pitchFamily="34" charset="-120"/>
-              </a:rPr>
-              <a:t>: no necesitas hacer todo de golpe</a:t>
+              <a:t>Escríbeme para definir y agendar tu horario recurrente de sesiones 1:1</a:t>
             </a:r>
             <a:endParaRPr lang="en-US" sz="1650" dirty="0"/>
           </a:p>
@@ -3738,12 +4374,12 @@
         </p:nvSpPr>
         <p:spPr>
           <a:xfrm>
-            <a:off x="4389120" y="2427732"/>
-            <a:ext cx="7159752" cy="946404"/>
+            <a:off x="4389120" y="2578608"/>
+            <a:ext cx="7159752" cy="1097280"/>
           </a:xfrm>
           <a:prstGeom prst="roundRect">
             <a:avLst>
-              <a:gd name="adj" fmla="val 15459"/>
+              <a:gd name="adj" fmla="val 13333"/>
             </a:avLst>
           </a:prstGeom>
           <a:solidFill>
@@ -3772,7 +4408,7 @@
         </p:nvSpPr>
         <p:spPr>
           <a:xfrm>
-            <a:off x="4709160" y="2599182"/>
+            <a:off x="4709160" y="2825496"/>
             <a:ext cx="603504" cy="603504"/>
           </a:xfrm>
           <a:prstGeom prst="ellipse">
@@ -3805,7 +4441,7 @@
         </p:blipFill>
         <p:spPr>
           <a:xfrm>
-            <a:off x="4872106" y="2762128"/>
+            <a:off x="4872106" y="2988442"/>
             <a:ext cx="277612" cy="277612"/>
           </a:xfrm>
           <a:prstGeom prst="rect">
@@ -3821,8 +4457,8 @@
         </p:nvSpPr>
         <p:spPr>
           <a:xfrm>
-            <a:off x="5577840" y="2427732"/>
-            <a:ext cx="5696712" cy="946404"/>
+            <a:off x="5577840" y="2578608"/>
+            <a:ext cx="5696712" cy="1097280"/>
           </a:xfrm>
           <a:prstGeom prst="rect">
             <a:avLst/>
@@ -3838,7 +4474,7 @@
               <a:buNone/>
             </a:pPr>
             <a:r>
-              <a:rPr lang="en-US" sz="1650" b="1" dirty="0">
+              <a:rPr lang="en-US" sz="1650" dirty="0">
                 <a:solidFill>
                   <a:srgbClr val="3F1E0D"/>
                 </a:solidFill>
@@ -3846,7 +4482,35 @@
                 <a:ea typeface="Open Sans" pitchFamily="34" charset="-122"/>
                 <a:cs typeface="Open Sans" pitchFamily="34" charset="-120"/>
               </a:rPr>
-              <a:t>Usa tu Weekly System</a:t>
+              <a:t>Después, empieza el Módulo 1: </a:t>
+            </a:r>
+            <a:pPr indent="0" marL="0">
+              <a:buNone/>
+            </a:pPr>
+            <a:r>
+              <a:rPr lang="en-US" sz="1650" b="1" dirty="0">
+                <a:solidFill>
+                  <a:srgbClr val="3F1E0D"/>
+                </a:solidFill>
+                <a:latin typeface="Open Sans" pitchFamily="34" charset="0"/>
+                <a:ea typeface="Open Sans" pitchFamily="34" charset="-122"/>
+                <a:cs typeface="Open Sans" pitchFamily="34" charset="-120"/>
+              </a:rPr>
+              <a:t>sigue el foco de cada semana</a:t>
+            </a:r>
+            <a:pPr indent="0" marL="0">
+              <a:buNone/>
+            </a:pPr>
+            <a:r>
+              <a:rPr lang="en-US" sz="1650" dirty="0">
+                <a:solidFill>
+                  <a:srgbClr val="3F1E0D"/>
+                </a:solidFill>
+                <a:latin typeface="Open Sans" pitchFamily="34" charset="0"/>
+                <a:ea typeface="Open Sans" pitchFamily="34" charset="-122"/>
+                <a:cs typeface="Open Sans" pitchFamily="34" charset="-120"/>
+              </a:rPr>
+              <a:t> y usa tu Weekly System</a:t>
             </a:r>
             <a:endParaRPr lang="en-US" sz="1650" dirty="0"/>
           </a:p>
@@ -3860,12 +4524,12 @@
         </p:nvSpPr>
         <p:spPr>
           <a:xfrm>
-            <a:off x="4389120" y="3575304"/>
-            <a:ext cx="7159752" cy="946404"/>
+            <a:off x="4389120" y="3877056"/>
+            <a:ext cx="7159752" cy="1097280"/>
           </a:xfrm>
           <a:prstGeom prst="roundRect">
             <a:avLst>
-              <a:gd name="adj" fmla="val 15459"/>
+              <a:gd name="adj" fmla="val 13333"/>
             </a:avLst>
           </a:prstGeom>
           <a:solidFill>
@@ -3894,7 +4558,7 @@
         </p:nvSpPr>
         <p:spPr>
           <a:xfrm>
-            <a:off x="4709160" y="3746754"/>
+            <a:off x="4709160" y="4123944"/>
             <a:ext cx="603504" cy="603504"/>
           </a:xfrm>
           <a:prstGeom prst="ellipse">
@@ -3927,7 +4591,7 @@
         </p:blipFill>
         <p:spPr>
           <a:xfrm>
-            <a:off x="4872106" y="3909700"/>
+            <a:off x="4872106" y="4286890"/>
             <a:ext cx="277612" cy="277612"/>
           </a:xfrm>
           <a:prstGeom prst="rect">
@@ -3943,8 +4607,8 @@
         </p:nvSpPr>
         <p:spPr>
           <a:xfrm>
-            <a:off x="5577840" y="3575304"/>
-            <a:ext cx="5696712" cy="946404"/>
+            <a:off x="5577840" y="3877056"/>
+            <a:ext cx="5696712" cy="1097280"/>
           </a:xfrm>
           <a:prstGeom prst="rect">
             <a:avLst/>
@@ -3982,116 +4646,8 @@
                 <a:ea typeface="Open Sans" pitchFamily="34" charset="-122"/>
                 <a:cs typeface="Open Sans" pitchFamily="34" charset="-120"/>
               </a:rPr>
-              <a:t> al proceso</a:t>
-            </a:r>
-            <a:endParaRPr lang="en-US" sz="1650" dirty="0"/>
-          </a:p>
-        </p:txBody>
-      </p:sp>
-      <p:sp>
-        <p:nvSpPr>
-          <p:cNvPr id="19" name="Shape 12"/>
-          <p:cNvSpPr/>
-          <p:nvPr/>
-        </p:nvSpPr>
-        <p:spPr>
-          <a:xfrm>
-            <a:off x="4389120" y="4722876"/>
-            <a:ext cx="7159752" cy="946404"/>
-          </a:xfrm>
-          <a:prstGeom prst="roundRect">
-            <a:avLst>
-              <a:gd name="adj" fmla="val 15459"/>
-            </a:avLst>
-          </a:prstGeom>
-          <a:solidFill>
-            <a:srgbClr val="F8F5EE"/>
-          </a:solidFill>
-          <a:ln w="12700">
-            <a:solidFill>
-              <a:srgbClr val="F8F5EE"/>
-            </a:solidFill>
-            <a:prstDash val="solid"/>
-          </a:ln>
-          <a:effectLst>
-            <a:outerShdw sx="100000" sy="100000" kx="0" ky="0" algn="bl" rotWithShape="0" blurRad="177800" dist="38100" dir="5400000">
-              <a:srgbClr val="3F1E0D">
-                <a:alpha val="10000"/>
-              </a:srgbClr>
-            </a:outerShdw>
-          </a:effectLst>
-        </p:spPr>
-      </p:sp>
-      <p:sp>
-        <p:nvSpPr>
-          <p:cNvPr id="20" name="Shape 13"/>
-          <p:cNvSpPr/>
-          <p:nvPr/>
-        </p:nvSpPr>
-        <p:spPr>
-          <a:xfrm>
-            <a:off x="4709160" y="4894326"/>
-            <a:ext cx="603504" cy="603504"/>
-          </a:xfrm>
-          <a:prstGeom prst="ellipse">
-            <a:avLst/>
-          </a:prstGeom>
-          <a:solidFill>
-            <a:srgbClr val="3F1E0D"/>
-          </a:solidFill>
-          <a:ln w="12700">
-            <a:solidFill>
-              <a:srgbClr val="3F1E0D"/>
-            </a:solidFill>
-            <a:prstDash val="solid"/>
-          </a:ln>
-        </p:spPr>
-      </p:sp>
-      <p:pic>
-        <p:nvPicPr>
-          <p:cNvPr id="21" name="Image 4" descr="preencoded.png">    </p:cNvPr>
-          <p:cNvPicPr>
-            <a:picLocks noChangeAspect="1"/>
-          </p:cNvPicPr>
-          <p:nvPr/>
-        </p:nvPicPr>
-        <p:blipFill>
-          <a:blip r:embed="rId5"/>
-          <a:stretch>
-            <a:fillRect/>
-          </a:stretch>
-        </p:blipFill>
-        <p:spPr>
-          <a:xfrm>
-            <a:off x="4872106" y="5057272"/>
-            <a:ext cx="277612" cy="277612"/>
-          </a:xfrm>
-          <a:prstGeom prst="rect">
-            <a:avLst/>
-          </a:prstGeom>
-        </p:spPr>
-      </p:pic>
-      <p:sp>
-        <p:nvSpPr>
-          <p:cNvPr id="22" name="Text 14"/>
-          <p:cNvSpPr txBox="1"/>
-          <p:nvPr/>
-        </p:nvSpPr>
-        <p:spPr>
-          <a:xfrm>
-            <a:off x="5577840" y="4722876"/>
-            <a:ext cx="5696712" cy="946404"/>
-          </a:xfrm>
-          <a:prstGeom prst="rect">
-            <a:avLst/>
-          </a:prstGeom>
-          <a:noFill/>
-          <a:ln/>
-        </p:spPr>
-        <p:txBody>
-          <a:bodyPr wrap="square" lIns="0" tIns="0" rIns="0" bIns="0" rtlCol="0" anchor="ctr"/>
-          <a:lstStyle/>
-          <a:p>
+              <a:t> al proceso y </a:t>
+            </a:r>
             <a:pPr indent="0" marL="0">
               <a:buNone/>
             </a:pPr>
@@ -4104,7 +4660,7 @@
                 <a:ea typeface="Open Sans" pitchFamily="34" charset="-122"/>
                 <a:cs typeface="Open Sans" pitchFamily="34" charset="-120"/>
               </a:rPr>
-              <a:t>Pide ayuda</a:t>
+              <a:t>pide ayuda</a:t>
             </a:r>
             <a:pPr indent="0" marL="0">
               <a:buNone/>
@@ -4126,7 +4682,7 @@
       </p:sp>
       <p:sp>
         <p:nvSpPr>
-          <p:cNvPr id="23" name="Text 15"/>
+          <p:cNvPr id="19" name="Text 12"/>
           <p:cNvSpPr txBox="1"/>
           <p:nvPr/>
         </p:nvSpPr>
@@ -4157,7 +4713,7 @@
                 <a:ea typeface="Source Serif Pro" pitchFamily="34" charset="-122"/>
                 <a:cs typeface="Source Serif Pro" pitchFamily="34" charset="-120"/>
               </a:rPr>
-              <a:t>No marques esta clase como completada hasta terminar todo el checklist. Cuando esté listo, tu onboarding está completo.</a:t>
+              <a:t>No avances al Módulo 1 ni marques esta clase como completada hasta haber terminado todos los puntos del checklist.</a:t>
             </a:r>
             <a:endParaRPr lang="en-US" sz="1500" dirty="0"/>
           </a:p>

</xml_diff>